<commit_message>
docs: add 4강 'AI 위임의 기술, 딸깍의 경계' deck + scripts; tie 딸깍 framing into 1강/3강
- 4강 (25 slides): 딸깍(위임) 정의·스펙트럼, 경계를 가르는 네 가지 질문(확인 가능·기준 명확·
  흔한 일·실패 비용)과 처방, 함정 두 가지, 남은 학기와의 연결, 경계 탐사 실험 4개(예측표 →
  로또/단위 변환기/할 일 관리 한방 vs 쪼개기/쇼핑몰은 예측만), TTS-ready 대본 포함
- 1강 s1 노트와 3강 s31 예고에 '얼마나 딸깍으로 가능한가' 프레이밍 연결

Co-Authored-By: Claude Fable 5 <noreply@anthropic.com>
</commit_message>
<xml_diff>
--- a/data/생성형 AI 소프트웨어공학/생성형AI소프트웨어공학_3강.pptx
+++ b/data/생성형 AI 소프트웨어공학/생성형AI소프트웨어공학_3강.pptx
@@ -3761,7 +3761,7 @@
           <a:p>
             <a:r>
               <a:rPr lang="ko-KR"/>
-              <a:t>다음 주 예고입니다. 4주차는 지시문 심화, 오늘 배운 네 기둥 위에 세 가지를 얹습니다.</a:t>
+              <a:t>다음 주 예고입니다. 4강의 제목은 딸깍의 경계입니다. 요즘 말로 딸깍, 그러니까 지시 한 번으로 끝나는 일과 그렇지 않은 일을 가르는 기준을 배우고, 실험으로 직접 재 봅니다. 4주차는 지시문 심화, 오늘 배운 네 기둥 위에 세 가지를 얹습니다.</a:t>
             </a:r>
           </a:p>
           <a:p/>
@@ -23909,7 +23909,7 @@
                 <a:ea typeface="Malgun Gothic" pitchFamily="34" charset="-122"/>
                 <a:cs typeface="Malgun Gothic" pitchFamily="34" charset="-120"/>
               </a:rPr>
-              <a:t>다음 주: 지시문 심화</a:t>
+              <a:t>다음 주: 지시문 심화, 딸깍의 경계</a:t>
             </a:r>
             <a:endParaRPr lang="en-US" sz="2600" dirty="0"/>
           </a:p>

</xml_diff>